<commit_message>
Prepare phase 1 review updates
Add password recovery handling and update Phase I review deliverables.

Document the pnpm build registry workaround for this workspace.
</commit_message>
<xml_diff>
--- a/college/mydeliverables/1st-Review/deck/review1-deck.pptx
+++ b/college/mydeliverables/1st-Review/deck/review1-deck.pptx
@@ -512,10 +512,13 @@
           <a:lstStyle/>
           <a:p>
             <a:r>
-              <a:rPr lang="en-US" dirty="0"/>
-              <a:t/>
-            </a:r>
-            <a:endParaRPr lang="en-US" dirty="0"/>
+              <a:t>Good morning, Professor — and welcome to any additional panel members. I am Rohit Saji, PES2PGE24DS201. This is my Phase I First Review for Adaptive Study Planning for Self-Directed Learners.</a:t>
+            </a:r>
+          </a:p>
+          <a:p>
+            <a:r>
+              <a:t>→ Walk the slide, then move quickly — this is a title slide.</a:t>
+            </a:r>
           </a:p>
         </p:txBody>
       </p:sp>
@@ -600,10 +603,13 @@
           <a:lstStyle/>
           <a:p>
             <a:r>
-              <a:rPr lang="en-US" dirty="0"/>
-              <a:t/>
-            </a:r>
-            <a:endParaRPr lang="en-US" dirty="0"/>
+              <a:t>Today = R1 (30%). June 21 = R2 (80%): generator built + comparison running + scheduler live. July 5 = R3 (100%): full results + demo + journal draft.</a:t>
+            </a:r>
+          </a:p>
+          <a:p>
+            <a:r>
+              <a:t>→ Phase II begins after July — that is where the loop closes.</a:t>
+            </a:r>
           </a:p>
         </p:txBody>
       </p:sp>
@@ -688,10 +694,13 @@
           <a:lstStyle/>
           <a:p>
             <a:r>
-              <a:rPr lang="en-US" dirty="0"/>
-              <a:t/>
-            </a:r>
-            <a:endParaRPr lang="en-US" dirty="0"/>
+              <a:t>The 30% = data-capture foundation: session logging, per-user event store, auth + cloud sync.</a:t>
+            </a:r>
+          </a:p>
+          <a:p>
+            <a:r>
+              <a:t>→ BUILT = the code. DESIGNED = 4-stage methodology + synthetic generator design + Pillar B architecture. The remaining 70% is Reviews 2 and 3.</a:t>
+            </a:r>
           </a:p>
         </p:txBody>
       </p:sp>
@@ -776,10 +785,13 @@
           <a:lstStyle/>
           <a:p>
             <a:r>
-              <a:rPr lang="en-US" dirty="0"/>
-              <a:t/>
-            </a:r>
-            <a:endParaRPr lang="en-US" dirty="0"/>
+              <a:t>Phase II closes the loop and builds Pillar B — the real novelty.</a:t>
+            </a:r>
+          </a:p>
+          <a:p>
+            <a:r>
+              <a:t>→ End with: 'Phase I gives us the validated open-loop baseline. Phase II is where we answer the thesis question: does verified, closed-loop adaptation beat open-loop self-reporting?'</a:t>
+            </a:r>
           </a:p>
         </p:txBody>
       </p:sp>
@@ -864,10 +876,13 @@
           <a:lstStyle/>
           <a:p>
             <a:r>
-              <a:rPr lang="en-US" dirty="0"/>
-              <a:t/>
-            </a:r>
-            <a:endParaRPr lang="en-US" dirty="0"/>
+              <a:t>Hook: Self-directed learners build plans that break within days, and self-reported time has no ground truth.</a:t>
+            </a:r>
+          </a:p>
+          <a:p>
+            <a:r>
+              <a:t>→ Key point: 'verified closed-loop' means the system checks whether learning happened, then adapts the schedule.</a:t>
+            </a:r>
           </a:p>
         </p:txBody>
       </p:sp>
@@ -952,10 +967,13 @@
           <a:lstStyle/>
           <a:p>
             <a:r>
-              <a:rPr lang="en-US" dirty="0"/>
-              <a:t/>
-            </a:r>
-            <a:endParaRPr lang="en-US" dirty="0"/>
+              <a:t>CRITICAL SLIDE. Open with: 'Professor, your question — how do you stop users passing false session data — reshaped this entire project.'</a:t>
+            </a:r>
+          </a:p>
+          <a:p>
+            <a:r>
+              <a:t>→ Pillar A = adaptation engine. Pillar B = verification signal. Neither works without the other.</a:t>
+            </a:r>
           </a:p>
         </p:txBody>
       </p:sp>
@@ -1040,10 +1058,13 @@
           <a:lstStyle/>
           <a:p>
             <a:r>
-              <a:rPr lang="en-US" dirty="0"/>
-              <a:t/>
-            </a:r>
-            <a:endParaRPr lang="en-US" dirty="0"/>
+              <a:t>Describe the diagram verbally: solid = Phase I (built/researching), dashed = Phase II (novelty), gold arrows = the closed feedback loop.</a:t>
+            </a:r>
+          </a:p>
+          <a:p>
+            <a:r>
+              <a:t>→ Three tiers: client app (bottom) → Python intelligence service (middle) → offline research (top). Supabase is the data hub.</a:t>
+            </a:r>
           </a:p>
         </p:txBody>
       </p:sp>
@@ -1128,10 +1149,13 @@
           <a:lstStyle/>
           <a:p>
             <a:r>
-              <a:rPr lang="en-US" dirty="0"/>
-              <a:t/>
-            </a:r>
-            <a:endParaRPr lang="en-US" dirty="0"/>
+              <a:t>Walk the pipeline left to right: (1) Bayesian calibration learns true pace, (2) CUSUM catches habit shifts, (3) GP gives a completion band not just a date, (4) constraint-based scheduler regenerates the plan.</a:t>
+            </a:r>
+          </a:p>
+          <a:p>
+            <a:r>
+              <a:t>→ Phase I computes calibration open-loop; Phase II closes it.</a:t>
+            </a:r>
           </a:p>
         </p:txBody>
       </p:sp>
@@ -1216,10 +1240,13 @@
           <a:lstStyle/>
           <a:p>
             <a:r>
-              <a:rPr lang="en-US" dirty="0"/>
-              <a:t/>
-            </a:r>
-            <a:endParaRPr lang="en-US" dirty="0"/>
+              <a:t>Design is decided; build is Phase II. Flow: ingest material → LLM generates questions → auto-grade → knowledge tracing → mastery estimate.</a:t>
+            </a:r>
+          </a:p>
+          <a:p>
+            <a:r>
+              <a:t>→ Key point: a timed, material-grounded test is hard to game — that is the valid verification signal.</a:t>
+            </a:r>
           </a:p>
         </p:txBody>
       </p:sp>
@@ -1304,10 +1331,13 @@
           <a:lstStyle/>
           <a:p>
             <a:r>
-              <a:rPr lang="en-US" dirty="0"/>
-              <a:t/>
-            </a:r>
-            <a:endParaRPr lang="en-US" dirty="0"/>
+              <a:t>48 papers, 12 anchors, 2 base papers (Islam 2024 for Pillar A; CLST 2024 for Pillar B).</a:t>
+            </a:r>
+          </a:p>
+          <a:p>
+            <a:r>
+              <a:t>→ THE GAP: nobody combines calibration + shift detection + uncertainty projection + adaptive scheduling into a verified closed loop. Each piece exists; the combination does not.</a:t>
+            </a:r>
           </a:p>
         </p:txBody>
       </p:sp>
@@ -1392,10 +1422,13 @@
           <a:lstStyle/>
           <a:p>
             <a:r>
-              <a:rPr lang="en-US" dirty="0"/>
-              <a:t/>
-            </a:r>
-            <a:endParaRPr lang="en-US" dirty="0"/>
+              <a:t>Four data sources: synthetic generator (known ground truth), pyKT public benchmarks (Eedi + POJ), honest-vs-faker overlay, N=1 real sessions.</a:t>
+            </a:r>
+          </a:p>
+          <a:p>
+            <a:r>
+              <a:t>→ Three-leg evaluation: synthetic ground truth + public benchmarks + closed-loop vs open-loop.</a:t>
+            </a:r>
           </a:p>
         </p:txBody>
       </p:sp>
@@ -1480,10 +1513,13 @@
           <a:lstStyle/>
           <a:p>
             <a:r>
-              <a:rPr lang="en-US" dirty="0"/>
-              <a:t/>
-            </a:r>
-            <a:endParaRPr lang="en-US" dirty="0"/>
+              <a:t>Directional hypotheses only — the only committed number is KT-AUC 0.70–0.82 (published benchmark range).</a:t>
+            </a:r>
+          </a:p>
+          <a:p>
+            <a:r>
+              <a:t>→ Walk key rows: Bayesian &lt; SMA error (sparse data); GP calibrated band vs overconfident linear; KT-AUC in benchmark range; high precision on fake-session detection.</a:t>
+            </a:r>
           </a:p>
         </p:txBody>
       </p:sp>

</xml_diff>